<commit_message>
Adiciona screenshot real do dashboard no slide de Produto
Slide 6 ("Produto — Como Funciona") reorganizado em duas colunas: os 4
passos do fluxo num grid 2x2 à esquerda, e à direita uma captura de tela
real do dashboard (live feed do RPA preenchendo CNPJ/Razão Social/sócios
extraídos do documento, painel de dados extraídos com confiança da IA, e o
histórico de automações) — prova visual direta de que o pipeline roda de
verdade, não é mockup.
</commit_message>
<xml_diff>
--- a/docs/apresentacao/GovFlow-AI-Apresentacao.pptx
+++ b/docs/apresentacao/GovFlow-AI-Apresentacao.pptx
@@ -9360,12 +9360,12 @@
         </p:nvSpPr>
         <p:spPr>
           <a:xfrm>
-            <a:off x="502920" y="2011680"/>
-            <a:ext cx="2651760" cy="2011680"/>
+            <a:off x="502920" y="1874520"/>
+            <a:ext cx="3177540" cy="1691640"/>
           </a:xfrm>
           <a:prstGeom prst="roundRect">
             <a:avLst>
-              <a:gd name="adj" fmla="val 6000"/>
+              <a:gd name="adj" fmla="val 7000"/>
             </a:avLst>
           </a:prstGeom>
           <a:solidFill>
@@ -9406,8 +9406,8 @@
         </p:nvSpPr>
         <p:spPr>
           <a:xfrm>
-            <a:off x="731520" y="2240280"/>
-            <a:ext cx="457200" cy="457200"/>
+            <a:off x="704088" y="2057400"/>
+            <a:ext cx="384048" cy="384048"/>
           </a:xfrm>
           <a:prstGeom prst="ellipse">
             <a:avLst/>
@@ -9440,7 +9440,7 @@
           <a:p>
             <a:pPr algn="ctr"/>
             <a:r>
-              <a:rPr sz="1500" b="1">
+              <a:rPr sz="1300" b="1">
                 <a:solidFill>
                   <a:srgbClr val="1E3D1A"/>
                 </a:solidFill>
@@ -9459,8 +9459,8 @@
         </p:nvSpPr>
         <p:spPr>
           <a:xfrm>
-            <a:off x="731520" y="2880360"/>
-            <a:ext cx="2194560" cy="320040"/>
+            <a:off x="704088" y="2569464"/>
+            <a:ext cx="2811780" cy="292608"/>
           </a:xfrm>
           <a:prstGeom prst="rect">
             <a:avLst/>
@@ -9479,7 +9479,7 @@
               </a:lnSpc>
             </a:pPr>
             <a:r>
-              <a:rPr sz="1350" b="1" i="0">
+              <a:rPr sz="1250" b="1" i="0">
                 <a:solidFill>
                   <a:srgbClr val="FFFFFF"/>
                 </a:solidFill>
@@ -9498,8 +9498,8 @@
         </p:nvSpPr>
         <p:spPr>
           <a:xfrm>
-            <a:off x="731520" y="3218688"/>
-            <a:ext cx="2194560" cy="731520"/>
+            <a:off x="704088" y="2880360"/>
+            <a:ext cx="2811780" cy="640080"/>
           </a:xfrm>
           <a:prstGeom prst="rect">
             <a:avLst/>
@@ -9514,33 +9514,79 @@
           <a:p>
             <a:pPr algn="l">
               <a:lnSpc>
-                <a:spcPct val="105000"/>
-              </a:lnSpc>
-            </a:pPr>
-            <a:r>
-              <a:rPr sz="1050" b="0" i="0">
+                <a:spcPct val="102000"/>
+              </a:lnSpc>
+            </a:pPr>
+            <a:r>
+              <a:rPr sz="950" b="0" i="0">
                 <a:solidFill>
                   <a:srgbClr val="B8D9B2"/>
                 </a:solidFill>
                 <a:latin typeface="Calibri"/>
               </a:rPr>
-              <a:t>Contador envia o documento pelo webchat ou pelo portal (login real via banco).</a:t>
-            </a:r>
-          </a:p>
-        </p:txBody>
-      </p:sp>
-      <p:sp>
-        <p:nvSpPr>
-          <p:cNvPr id="14" name="Right Arrow 13"/>
+              <a:t>Documento pelo webchat ou portal (login real via banco).</a:t>
+            </a:r>
+          </a:p>
+        </p:txBody>
+      </p:sp>
+      <p:sp>
+        <p:nvSpPr>
+          <p:cNvPr id="14" name="Rounded Rectangle 13"/>
           <p:cNvSpPr/>
           <p:nvPr/>
         </p:nvSpPr>
         <p:spPr>
           <a:xfrm>
-            <a:off x="3182112" y="2907792"/>
-            <a:ext cx="146304" cy="219456"/>
-          </a:xfrm>
-          <a:prstGeom prst="rightArrow">
+            <a:off x="3863340" y="1874520"/>
+            <a:ext cx="3177540" cy="1691640"/>
+          </a:xfrm>
+          <a:prstGeom prst="roundRect">
+            <a:avLst>
+              <a:gd name="adj" fmla="val 7000"/>
+            </a:avLst>
+          </a:prstGeom>
+          <a:solidFill>
+            <a:srgbClr val="244A1F"/>
+          </a:solidFill>
+          <a:ln>
+            <a:noFill/>
+          </a:ln>
+          <a:effectLst/>
+        </p:spPr>
+        <p:style>
+          <a:lnRef idx="1">
+            <a:schemeClr val="accent1"/>
+          </a:lnRef>
+          <a:fillRef idx="3">
+            <a:schemeClr val="accent1"/>
+          </a:fillRef>
+          <a:effectRef idx="2">
+            <a:schemeClr val="accent1"/>
+          </a:effectRef>
+          <a:fontRef idx="minor">
+            <a:schemeClr val="lt1"/>
+          </a:fontRef>
+        </p:style>
+        <p:txBody>
+          <a:bodyPr rtlCol="0" anchor="ctr"/>
+          <a:lstStyle/>
+          <a:p>
+            <a:pPr algn="ctr"/>
+          </a:p>
+        </p:txBody>
+      </p:sp>
+      <p:sp>
+        <p:nvSpPr>
+          <p:cNvPr id="15" name="Oval 14"/>
+          <p:cNvSpPr/>
+          <p:nvPr/>
+        </p:nvSpPr>
+        <p:spPr>
+          <a:xfrm>
+            <a:off x="4064508" y="2057400"/>
+            <a:ext cx="384048" cy="384048"/>
+          </a:xfrm>
+          <a:prstGeom prst="ellipse">
             <a:avLst/>
           </a:prstGeom>
           <a:solidFill>
@@ -9566,27 +9612,114 @@
           </a:fontRef>
         </p:style>
         <p:txBody>
-          <a:bodyPr rtlCol="0" anchor="ctr"/>
+          <a:bodyPr rtlCol="0" anchor="ctr" lIns="0" rIns="0"/>
           <a:lstStyle/>
           <a:p>
             <a:pPr algn="ctr"/>
-          </a:p>
-        </p:txBody>
-      </p:sp>
-      <p:sp>
-        <p:nvSpPr>
-          <p:cNvPr id="15" name="Rounded Rectangle 14"/>
+            <a:r>
+              <a:rPr sz="1300" b="1">
+                <a:solidFill>
+                  <a:srgbClr val="1E3D1A"/>
+                </a:solidFill>
+                <a:latin typeface="Calibri"/>
+              </a:rPr>
+              <a:t>2</a:t>
+            </a:r>
+          </a:p>
+        </p:txBody>
+      </p:sp>
+      <p:sp>
+        <p:nvSpPr>
+          <p:cNvPr id="16" name="TextBox 15"/>
+          <p:cNvSpPr txBox="1"/>
+          <p:nvPr/>
+        </p:nvSpPr>
+        <p:spPr>
+          <a:xfrm>
+            <a:off x="4064508" y="2569464"/>
+            <a:ext cx="2811780" cy="292608"/>
+          </a:xfrm>
+          <a:prstGeom prst="rect">
+            <a:avLst/>
+          </a:prstGeom>
+          <a:noFill/>
+        </p:spPr>
+        <p:txBody>
+          <a:bodyPr wrap="square" anchor="t" lIns="0" rIns="0" tIns="0" bIns="0">
+            <a:spAutoFit/>
+          </a:bodyPr>
+          <a:lstStyle/>
+          <a:p>
+            <a:pPr algn="l">
+              <a:lnSpc>
+                <a:spcPct val="100000"/>
+              </a:lnSpc>
+            </a:pPr>
+            <a:r>
+              <a:rPr sz="1250" b="1" i="0">
+                <a:solidFill>
+                  <a:srgbClr val="FFFFFF"/>
+                </a:solidFill>
+                <a:latin typeface="Calibri"/>
+              </a:rPr>
+              <a:t>Extração (IA)</a:t>
+            </a:r>
+          </a:p>
+        </p:txBody>
+      </p:sp>
+      <p:sp>
+        <p:nvSpPr>
+          <p:cNvPr id="17" name="TextBox 16"/>
+          <p:cNvSpPr txBox="1"/>
+          <p:nvPr/>
+        </p:nvSpPr>
+        <p:spPr>
+          <a:xfrm>
+            <a:off x="4064508" y="2880360"/>
+            <a:ext cx="2811780" cy="640080"/>
+          </a:xfrm>
+          <a:prstGeom prst="rect">
+            <a:avLst/>
+          </a:prstGeom>
+          <a:noFill/>
+        </p:spPr>
+        <p:txBody>
+          <a:bodyPr wrap="square" anchor="t" lIns="0" rIns="0" tIns="0" bIns="0">
+            <a:spAutoFit/>
+          </a:bodyPr>
+          <a:lstStyle/>
+          <a:p>
+            <a:pPr algn="l">
+              <a:lnSpc>
+                <a:spcPct val="102000"/>
+              </a:lnSpc>
+            </a:pPr>
+            <a:r>
+              <a:rPr sz="950" b="0" i="0">
+                <a:solidFill>
+                  <a:srgbClr val="B8D9B2"/>
+                </a:solidFill>
+                <a:latin typeface="Calibri"/>
+              </a:rPr>
+              <a:t>OCR + NLP lê CNPJ, Razão Social, Capital, sócios.</a:t>
+            </a:r>
+          </a:p>
+        </p:txBody>
+      </p:sp>
+      <p:sp>
+        <p:nvSpPr>
+          <p:cNvPr id="18" name="Rounded Rectangle 17"/>
           <p:cNvSpPr/>
           <p:nvPr/>
         </p:nvSpPr>
         <p:spPr>
           <a:xfrm>
-            <a:off x="3337560" y="2011680"/>
-            <a:ext cx="2651760" cy="2011680"/>
+            <a:off x="502920" y="3703320"/>
+            <a:ext cx="3177540" cy="1691640"/>
           </a:xfrm>
           <a:prstGeom prst="roundRect">
             <a:avLst>
-              <a:gd name="adj" fmla="val 6000"/>
+              <a:gd name="adj" fmla="val 7000"/>
             </a:avLst>
           </a:prstGeom>
           <a:solidFill>
@@ -9621,14 +9754,14 @@
       </p:sp>
       <p:sp>
         <p:nvSpPr>
-          <p:cNvPr id="16" name="Oval 15"/>
+          <p:cNvPr id="19" name="Oval 18"/>
           <p:cNvSpPr/>
           <p:nvPr/>
         </p:nvSpPr>
         <p:spPr>
           <a:xfrm>
-            <a:off x="3566160" y="2240280"/>
-            <a:ext cx="457200" cy="457200"/>
+            <a:off x="704088" y="3886200"/>
+            <a:ext cx="384048" cy="384048"/>
           </a:xfrm>
           <a:prstGeom prst="ellipse">
             <a:avLst/>
@@ -9661,27 +9794,27 @@
           <a:p>
             <a:pPr algn="ctr"/>
             <a:r>
-              <a:rPr sz="1500" b="1">
+              <a:rPr sz="1300" b="1">
                 <a:solidFill>
                   <a:srgbClr val="1E3D1A"/>
                 </a:solidFill>
                 <a:latin typeface="Calibri"/>
               </a:rPr>
-              <a:t>2</a:t>
-            </a:r>
-          </a:p>
-        </p:txBody>
-      </p:sp>
-      <p:sp>
-        <p:nvSpPr>
-          <p:cNvPr id="17" name="TextBox 16"/>
-          <p:cNvSpPr txBox="1"/>
-          <p:nvPr/>
-        </p:nvSpPr>
-        <p:spPr>
-          <a:xfrm>
-            <a:off x="3566160" y="2880360"/>
-            <a:ext cx="2194560" cy="320040"/>
+              <a:t>3</a:t>
+            </a:r>
+          </a:p>
+        </p:txBody>
+      </p:sp>
+      <p:sp>
+        <p:nvSpPr>
+          <p:cNvPr id="20" name="TextBox 19"/>
+          <p:cNvSpPr txBox="1"/>
+          <p:nvPr/>
+        </p:nvSpPr>
+        <p:spPr>
+          <a:xfrm>
+            <a:off x="704088" y="4398264"/>
+            <a:ext cx="2811780" cy="292608"/>
           </a:xfrm>
           <a:prstGeom prst="rect">
             <a:avLst/>
@@ -9700,27 +9833,27 @@
               </a:lnSpc>
             </a:pPr>
             <a:r>
-              <a:rPr sz="1350" b="1" i="0">
+              <a:rPr sz="1250" b="1" i="0">
                 <a:solidFill>
                   <a:srgbClr val="FFFFFF"/>
                 </a:solidFill>
                 <a:latin typeface="Calibri"/>
               </a:rPr>
-              <a:t>Extração (IA)</a:t>
-            </a:r>
-          </a:p>
-        </p:txBody>
-      </p:sp>
-      <p:sp>
-        <p:nvSpPr>
-          <p:cNvPr id="18" name="TextBox 17"/>
-          <p:cNvSpPr txBox="1"/>
-          <p:nvPr/>
-        </p:nvSpPr>
-        <p:spPr>
-          <a:xfrm>
-            <a:off x="3566160" y="3218688"/>
-            <a:ext cx="2194560" cy="731520"/>
+              <a:t>Confirmação</a:t>
+            </a:r>
+          </a:p>
+        </p:txBody>
+      </p:sp>
+      <p:sp>
+        <p:nvSpPr>
+          <p:cNvPr id="21" name="TextBox 20"/>
+          <p:cNvSpPr txBox="1"/>
+          <p:nvPr/>
+        </p:nvSpPr>
+        <p:spPr>
+          <a:xfrm>
+            <a:off x="704088" y="4709160"/>
+            <a:ext cx="2811780" cy="640080"/>
           </a:xfrm>
           <a:prstGeom prst="rect">
             <a:avLst/>
@@ -9735,33 +9868,79 @@
           <a:p>
             <a:pPr algn="l">
               <a:lnSpc>
-                <a:spcPct val="105000"/>
-              </a:lnSpc>
-            </a:pPr>
-            <a:r>
-              <a:rPr sz="1050" b="0" i="0">
+                <a:spcPct val="102000"/>
+              </a:lnSpc>
+            </a:pPr>
+            <a:r>
+              <a:rPr sz="950" b="0" i="0">
                 <a:solidFill>
                   <a:srgbClr val="B8D9B2"/>
                 </a:solidFill>
                 <a:latin typeface="Calibri"/>
               </a:rPr>
-              <a:t>OCR + NLP lê CNPJ, Razão Social, Capital Social e sócios do documento.</a:t>
-            </a:r>
-          </a:p>
-        </p:txBody>
-      </p:sp>
-      <p:sp>
-        <p:nvSpPr>
-          <p:cNvPr id="19" name="Right Arrow 18"/>
+              <a:t>Usuário revisa e clica em "Enviar ao Gov.br".</a:t>
+            </a:r>
+          </a:p>
+        </p:txBody>
+      </p:sp>
+      <p:sp>
+        <p:nvSpPr>
+          <p:cNvPr id="22" name="Rounded Rectangle 21"/>
           <p:cNvSpPr/>
           <p:nvPr/>
         </p:nvSpPr>
         <p:spPr>
           <a:xfrm>
-            <a:off x="6016752" y="2907792"/>
-            <a:ext cx="146304" cy="219456"/>
-          </a:xfrm>
-          <a:prstGeom prst="rightArrow">
+            <a:off x="3863340" y="3703320"/>
+            <a:ext cx="3177540" cy="1691640"/>
+          </a:xfrm>
+          <a:prstGeom prst="roundRect">
+            <a:avLst>
+              <a:gd name="adj" fmla="val 7000"/>
+            </a:avLst>
+          </a:prstGeom>
+          <a:solidFill>
+            <a:srgbClr val="244A1F"/>
+          </a:solidFill>
+          <a:ln>
+            <a:noFill/>
+          </a:ln>
+          <a:effectLst/>
+        </p:spPr>
+        <p:style>
+          <a:lnRef idx="1">
+            <a:schemeClr val="accent1"/>
+          </a:lnRef>
+          <a:fillRef idx="3">
+            <a:schemeClr val="accent1"/>
+          </a:fillRef>
+          <a:effectRef idx="2">
+            <a:schemeClr val="accent1"/>
+          </a:effectRef>
+          <a:fontRef idx="minor">
+            <a:schemeClr val="lt1"/>
+          </a:fontRef>
+        </p:style>
+        <p:txBody>
+          <a:bodyPr rtlCol="0" anchor="ctr"/>
+          <a:lstStyle/>
+          <a:p>
+            <a:pPr algn="ctr"/>
+          </a:p>
+        </p:txBody>
+      </p:sp>
+      <p:sp>
+        <p:nvSpPr>
+          <p:cNvPr id="23" name="Oval 22"/>
+          <p:cNvSpPr/>
+          <p:nvPr/>
+        </p:nvSpPr>
+        <p:spPr>
+          <a:xfrm>
+            <a:off x="4064508" y="3886200"/>
+            <a:ext cx="384048" cy="384048"/>
+          </a:xfrm>
+          <a:prstGeom prst="ellipse">
             <a:avLst/>
           </a:prstGeom>
           <a:solidFill>
@@ -9787,425 +9966,114 @@
           </a:fontRef>
         </p:style>
         <p:txBody>
-          <a:bodyPr rtlCol="0" anchor="ctr"/>
+          <a:bodyPr rtlCol="0" anchor="ctr" lIns="0" rIns="0"/>
           <a:lstStyle/>
           <a:p>
             <a:pPr algn="ctr"/>
-          </a:p>
-        </p:txBody>
-      </p:sp>
-      <p:sp>
-        <p:nvSpPr>
-          <p:cNvPr id="20" name="Rounded Rectangle 19"/>
+            <a:r>
+              <a:rPr sz="1300" b="1">
+                <a:solidFill>
+                  <a:srgbClr val="1E3D1A"/>
+                </a:solidFill>
+                <a:latin typeface="Calibri"/>
+              </a:rPr>
+              <a:t>4</a:t>
+            </a:r>
+          </a:p>
+        </p:txBody>
+      </p:sp>
+      <p:sp>
+        <p:nvSpPr>
+          <p:cNvPr id="24" name="TextBox 23"/>
+          <p:cNvSpPr txBox="1"/>
+          <p:nvPr/>
+        </p:nvSpPr>
+        <p:spPr>
+          <a:xfrm>
+            <a:off x="4064508" y="4398264"/>
+            <a:ext cx="2811780" cy="292608"/>
+          </a:xfrm>
+          <a:prstGeom prst="rect">
+            <a:avLst/>
+          </a:prstGeom>
+          <a:noFill/>
+        </p:spPr>
+        <p:txBody>
+          <a:bodyPr wrap="square" anchor="t" lIns="0" rIns="0" tIns="0" bIns="0">
+            <a:spAutoFit/>
+          </a:bodyPr>
+          <a:lstStyle/>
+          <a:p>
+            <a:pPr algn="l">
+              <a:lnSpc>
+                <a:spcPct val="100000"/>
+              </a:lnSpc>
+            </a:pPr>
+            <a:r>
+              <a:rPr sz="1250" b="1" i="0">
+                <a:solidFill>
+                  <a:srgbClr val="FFFFFF"/>
+                </a:solidFill>
+                <a:latin typeface="Calibri"/>
+              </a:rPr>
+              <a:t>RPA + Protocolo</a:t>
+            </a:r>
+          </a:p>
+        </p:txBody>
+      </p:sp>
+      <p:sp>
+        <p:nvSpPr>
+          <p:cNvPr id="25" name="TextBox 24"/>
+          <p:cNvSpPr txBox="1"/>
+          <p:nvPr/>
+        </p:nvSpPr>
+        <p:spPr>
+          <a:xfrm>
+            <a:off x="4064508" y="4709160"/>
+            <a:ext cx="2811780" cy="640080"/>
+          </a:xfrm>
+          <a:prstGeom prst="rect">
+            <a:avLst/>
+          </a:prstGeom>
+          <a:noFill/>
+        </p:spPr>
+        <p:txBody>
+          <a:bodyPr wrap="square" anchor="t" lIns="0" rIns="0" tIns="0" bIns="0">
+            <a:spAutoFit/>
+          </a:bodyPr>
+          <a:lstStyle/>
+          <a:p>
+            <a:pPr algn="l">
+              <a:lnSpc>
+                <a:spcPct val="102000"/>
+              </a:lnSpc>
+            </a:pPr>
+            <a:r>
+              <a:rPr sz="950" b="0" i="0">
+                <a:solidFill>
+                  <a:srgbClr val="B8D9B2"/>
+                </a:solidFill>
+                <a:latin typeface="Calibri"/>
+              </a:rPr>
+              <a:t>Robô preenche o portal e devolve o protocolo.</a:t>
+            </a:r>
+          </a:p>
+        </p:txBody>
+      </p:sp>
+      <p:sp>
+        <p:nvSpPr>
+          <p:cNvPr id="26" name="Rounded Rectangle 25"/>
           <p:cNvSpPr/>
           <p:nvPr/>
         </p:nvSpPr>
         <p:spPr>
           <a:xfrm>
-            <a:off x="6172200" y="2011680"/>
-            <a:ext cx="2651760" cy="2011680"/>
+            <a:off x="502920" y="5623560"/>
+            <a:ext cx="6537960" cy="1051560"/>
           </a:xfrm>
           <a:prstGeom prst="roundRect">
             <a:avLst>
               <a:gd name="adj" fmla="val 6000"/>
-            </a:avLst>
-          </a:prstGeom>
-          <a:solidFill>
-            <a:srgbClr val="244A1F"/>
-          </a:solidFill>
-          <a:ln>
-            <a:noFill/>
-          </a:ln>
-          <a:effectLst/>
-        </p:spPr>
-        <p:style>
-          <a:lnRef idx="1">
-            <a:schemeClr val="accent1"/>
-          </a:lnRef>
-          <a:fillRef idx="3">
-            <a:schemeClr val="accent1"/>
-          </a:fillRef>
-          <a:effectRef idx="2">
-            <a:schemeClr val="accent1"/>
-          </a:effectRef>
-          <a:fontRef idx="minor">
-            <a:schemeClr val="lt1"/>
-          </a:fontRef>
-        </p:style>
-        <p:txBody>
-          <a:bodyPr rtlCol="0" anchor="ctr"/>
-          <a:lstStyle/>
-          <a:p>
-            <a:pPr algn="ctr"/>
-          </a:p>
-        </p:txBody>
-      </p:sp>
-      <p:sp>
-        <p:nvSpPr>
-          <p:cNvPr id="21" name="Oval 20"/>
-          <p:cNvSpPr/>
-          <p:nvPr/>
-        </p:nvSpPr>
-        <p:spPr>
-          <a:xfrm>
-            <a:off x="6400800" y="2240280"/>
-            <a:ext cx="457200" cy="457200"/>
-          </a:xfrm>
-          <a:prstGeom prst="ellipse">
-            <a:avLst/>
-          </a:prstGeom>
-          <a:solidFill>
-            <a:srgbClr val="5A9E50"/>
-          </a:solidFill>
-          <a:ln>
-            <a:noFill/>
-          </a:ln>
-          <a:effectLst/>
-        </p:spPr>
-        <p:style>
-          <a:lnRef idx="1">
-            <a:schemeClr val="accent1"/>
-          </a:lnRef>
-          <a:fillRef idx="3">
-            <a:schemeClr val="accent1"/>
-          </a:fillRef>
-          <a:effectRef idx="2">
-            <a:schemeClr val="accent1"/>
-          </a:effectRef>
-          <a:fontRef idx="minor">
-            <a:schemeClr val="lt1"/>
-          </a:fontRef>
-        </p:style>
-        <p:txBody>
-          <a:bodyPr rtlCol="0" anchor="ctr" lIns="0" rIns="0"/>
-          <a:lstStyle/>
-          <a:p>
-            <a:pPr algn="ctr"/>
-            <a:r>
-              <a:rPr sz="1500" b="1">
-                <a:solidFill>
-                  <a:srgbClr val="1E3D1A"/>
-                </a:solidFill>
-                <a:latin typeface="Calibri"/>
-              </a:rPr>
-              <a:t>3</a:t>
-            </a:r>
-          </a:p>
-        </p:txBody>
-      </p:sp>
-      <p:sp>
-        <p:nvSpPr>
-          <p:cNvPr id="22" name="TextBox 21"/>
-          <p:cNvSpPr txBox="1"/>
-          <p:nvPr/>
-        </p:nvSpPr>
-        <p:spPr>
-          <a:xfrm>
-            <a:off x="6400800" y="2880360"/>
-            <a:ext cx="2194560" cy="320040"/>
-          </a:xfrm>
-          <a:prstGeom prst="rect">
-            <a:avLst/>
-          </a:prstGeom>
-          <a:noFill/>
-        </p:spPr>
-        <p:txBody>
-          <a:bodyPr wrap="square" anchor="t" lIns="0" rIns="0" tIns="0" bIns="0">
-            <a:spAutoFit/>
-          </a:bodyPr>
-          <a:lstStyle/>
-          <a:p>
-            <a:pPr algn="l">
-              <a:lnSpc>
-                <a:spcPct val="100000"/>
-              </a:lnSpc>
-            </a:pPr>
-            <a:r>
-              <a:rPr sz="1350" b="1" i="0">
-                <a:solidFill>
-                  <a:srgbClr val="FFFFFF"/>
-                </a:solidFill>
-                <a:latin typeface="Calibri"/>
-              </a:rPr>
-              <a:t>Confirmação</a:t>
-            </a:r>
-          </a:p>
-        </p:txBody>
-      </p:sp>
-      <p:sp>
-        <p:nvSpPr>
-          <p:cNvPr id="23" name="TextBox 22"/>
-          <p:cNvSpPr txBox="1"/>
-          <p:nvPr/>
-        </p:nvSpPr>
-        <p:spPr>
-          <a:xfrm>
-            <a:off x="6400800" y="3218688"/>
-            <a:ext cx="2194560" cy="731520"/>
-          </a:xfrm>
-          <a:prstGeom prst="rect">
-            <a:avLst/>
-          </a:prstGeom>
-          <a:noFill/>
-        </p:spPr>
-        <p:txBody>
-          <a:bodyPr wrap="square" anchor="t" lIns="0" rIns="0" tIns="0" bIns="0">
-            <a:spAutoFit/>
-          </a:bodyPr>
-          <a:lstStyle/>
-          <a:p>
-            <a:pPr algn="l">
-              <a:lnSpc>
-                <a:spcPct val="105000"/>
-              </a:lnSpc>
-            </a:pPr>
-            <a:r>
-              <a:rPr sz="1050" b="0" i="0">
-                <a:solidFill>
-                  <a:srgbClr val="B8D9B2"/>
-                </a:solidFill>
-                <a:latin typeface="Calibri"/>
-              </a:rPr>
-              <a:t>Usuário revisa os dados extraídos e clica em "Enviar ao Gov.br".</a:t>
-            </a:r>
-          </a:p>
-        </p:txBody>
-      </p:sp>
-      <p:sp>
-        <p:nvSpPr>
-          <p:cNvPr id="24" name="Right Arrow 23"/>
-          <p:cNvSpPr/>
-          <p:nvPr/>
-        </p:nvSpPr>
-        <p:spPr>
-          <a:xfrm>
-            <a:off x="8851392" y="2907792"/>
-            <a:ext cx="146304" cy="219456"/>
-          </a:xfrm>
-          <a:prstGeom prst="rightArrow">
-            <a:avLst/>
-          </a:prstGeom>
-          <a:solidFill>
-            <a:srgbClr val="5A9E50"/>
-          </a:solidFill>
-          <a:ln>
-            <a:noFill/>
-          </a:ln>
-          <a:effectLst/>
-        </p:spPr>
-        <p:style>
-          <a:lnRef idx="1">
-            <a:schemeClr val="accent1"/>
-          </a:lnRef>
-          <a:fillRef idx="3">
-            <a:schemeClr val="accent1"/>
-          </a:fillRef>
-          <a:effectRef idx="2">
-            <a:schemeClr val="accent1"/>
-          </a:effectRef>
-          <a:fontRef idx="minor">
-            <a:schemeClr val="lt1"/>
-          </a:fontRef>
-        </p:style>
-        <p:txBody>
-          <a:bodyPr rtlCol="0" anchor="ctr"/>
-          <a:lstStyle/>
-          <a:p>
-            <a:pPr algn="ctr"/>
-          </a:p>
-        </p:txBody>
-      </p:sp>
-      <p:sp>
-        <p:nvSpPr>
-          <p:cNvPr id="25" name="Rounded Rectangle 24"/>
-          <p:cNvSpPr/>
-          <p:nvPr/>
-        </p:nvSpPr>
-        <p:spPr>
-          <a:xfrm>
-            <a:off x="9006840" y="2011680"/>
-            <a:ext cx="2651760" cy="2011680"/>
-          </a:xfrm>
-          <a:prstGeom prst="roundRect">
-            <a:avLst>
-              <a:gd name="adj" fmla="val 6000"/>
-            </a:avLst>
-          </a:prstGeom>
-          <a:solidFill>
-            <a:srgbClr val="244A1F"/>
-          </a:solidFill>
-          <a:ln>
-            <a:noFill/>
-          </a:ln>
-          <a:effectLst/>
-        </p:spPr>
-        <p:style>
-          <a:lnRef idx="1">
-            <a:schemeClr val="accent1"/>
-          </a:lnRef>
-          <a:fillRef idx="3">
-            <a:schemeClr val="accent1"/>
-          </a:fillRef>
-          <a:effectRef idx="2">
-            <a:schemeClr val="accent1"/>
-          </a:effectRef>
-          <a:fontRef idx="minor">
-            <a:schemeClr val="lt1"/>
-          </a:fontRef>
-        </p:style>
-        <p:txBody>
-          <a:bodyPr rtlCol="0" anchor="ctr"/>
-          <a:lstStyle/>
-          <a:p>
-            <a:pPr algn="ctr"/>
-          </a:p>
-        </p:txBody>
-      </p:sp>
-      <p:sp>
-        <p:nvSpPr>
-          <p:cNvPr id="26" name="Oval 25"/>
-          <p:cNvSpPr/>
-          <p:nvPr/>
-        </p:nvSpPr>
-        <p:spPr>
-          <a:xfrm>
-            <a:off x="9235440" y="2240280"/>
-            <a:ext cx="457200" cy="457200"/>
-          </a:xfrm>
-          <a:prstGeom prst="ellipse">
-            <a:avLst/>
-          </a:prstGeom>
-          <a:solidFill>
-            <a:srgbClr val="5A9E50"/>
-          </a:solidFill>
-          <a:ln>
-            <a:noFill/>
-          </a:ln>
-          <a:effectLst/>
-        </p:spPr>
-        <p:style>
-          <a:lnRef idx="1">
-            <a:schemeClr val="accent1"/>
-          </a:lnRef>
-          <a:fillRef idx="3">
-            <a:schemeClr val="accent1"/>
-          </a:fillRef>
-          <a:effectRef idx="2">
-            <a:schemeClr val="accent1"/>
-          </a:effectRef>
-          <a:fontRef idx="minor">
-            <a:schemeClr val="lt1"/>
-          </a:fontRef>
-        </p:style>
-        <p:txBody>
-          <a:bodyPr rtlCol="0" anchor="ctr" lIns="0" rIns="0"/>
-          <a:lstStyle/>
-          <a:p>
-            <a:pPr algn="ctr"/>
-            <a:r>
-              <a:rPr sz="1500" b="1">
-                <a:solidFill>
-                  <a:srgbClr val="1E3D1A"/>
-                </a:solidFill>
-                <a:latin typeface="Calibri"/>
-              </a:rPr>
-              <a:t>4</a:t>
-            </a:r>
-          </a:p>
-        </p:txBody>
-      </p:sp>
-      <p:sp>
-        <p:nvSpPr>
-          <p:cNvPr id="27" name="TextBox 26"/>
-          <p:cNvSpPr txBox="1"/>
-          <p:nvPr/>
-        </p:nvSpPr>
-        <p:spPr>
-          <a:xfrm>
-            <a:off x="9235440" y="2880360"/>
-            <a:ext cx="2194560" cy="320040"/>
-          </a:xfrm>
-          <a:prstGeom prst="rect">
-            <a:avLst/>
-          </a:prstGeom>
-          <a:noFill/>
-        </p:spPr>
-        <p:txBody>
-          <a:bodyPr wrap="square" anchor="t" lIns="0" rIns="0" tIns="0" bIns="0">
-            <a:spAutoFit/>
-          </a:bodyPr>
-          <a:lstStyle/>
-          <a:p>
-            <a:pPr algn="l">
-              <a:lnSpc>
-                <a:spcPct val="100000"/>
-              </a:lnSpc>
-            </a:pPr>
-            <a:r>
-              <a:rPr sz="1350" b="1" i="0">
-                <a:solidFill>
-                  <a:srgbClr val="FFFFFF"/>
-                </a:solidFill>
-                <a:latin typeface="Calibri"/>
-              </a:rPr>
-              <a:t>RPA + Protocolo</a:t>
-            </a:r>
-          </a:p>
-        </p:txBody>
-      </p:sp>
-      <p:sp>
-        <p:nvSpPr>
-          <p:cNvPr id="28" name="TextBox 27"/>
-          <p:cNvSpPr txBox="1"/>
-          <p:nvPr/>
-        </p:nvSpPr>
-        <p:spPr>
-          <a:xfrm>
-            <a:off x="9235440" y="3218688"/>
-            <a:ext cx="2194560" cy="731520"/>
-          </a:xfrm>
-          <a:prstGeom prst="rect">
-            <a:avLst/>
-          </a:prstGeom>
-          <a:noFill/>
-        </p:spPr>
-        <p:txBody>
-          <a:bodyPr wrap="square" anchor="t" lIns="0" rIns="0" tIns="0" bIns="0">
-            <a:spAutoFit/>
-          </a:bodyPr>
-          <a:lstStyle/>
-          <a:p>
-            <a:pPr algn="l">
-              <a:lnSpc>
-                <a:spcPct val="105000"/>
-              </a:lnSpc>
-            </a:pPr>
-            <a:r>
-              <a:rPr sz="1050" b="0" i="0">
-                <a:solidFill>
-                  <a:srgbClr val="B8D9B2"/>
-                </a:solidFill>
-                <a:latin typeface="Calibri"/>
-              </a:rPr>
-              <a:t>Robô preenche o portal e devolve o protocolo, gravado no banco em nuvem.</a:t>
-            </a:r>
-          </a:p>
-        </p:txBody>
-      </p:sp>
-      <p:sp>
-        <p:nvSpPr>
-          <p:cNvPr id="29" name="Rounded Rectangle 28"/>
-          <p:cNvSpPr/>
-          <p:nvPr/>
-        </p:nvSpPr>
-        <p:spPr>
-          <a:xfrm>
-            <a:off x="502920" y="4389120"/>
-            <a:ext cx="11155680" cy="960120"/>
-          </a:xfrm>
-          <a:prstGeom prst="roundRect">
-            <a:avLst>
-              <a:gd name="adj" fmla="val 5000"/>
             </a:avLst>
           </a:prstGeom>
           <a:solidFill>
@@ -10240,14 +10108,14 @@
       </p:sp>
       <p:sp>
         <p:nvSpPr>
-          <p:cNvPr id="30" name="TextBox 29"/>
-          <p:cNvSpPr txBox="1"/>
-          <p:nvPr/>
-        </p:nvSpPr>
-        <p:spPr>
-          <a:xfrm>
-            <a:off x="777240" y="4526280"/>
-            <a:ext cx="10607040" cy="320040"/>
+          <p:cNvPr id="27" name="TextBox 26"/>
+          <p:cNvSpPr txBox="1"/>
+          <p:nvPr/>
+        </p:nvSpPr>
+        <p:spPr>
+          <a:xfrm>
+            <a:off x="731520" y="5760720"/>
+            <a:ext cx="6080760" cy="292608"/>
           </a:xfrm>
           <a:prstGeom prst="rect">
             <a:avLst/>
@@ -10266,7 +10134,7 @@
               </a:lnSpc>
             </a:pPr>
             <a:r>
-              <a:rPr sz="1300" b="1" i="0">
+              <a:rPr sz="1250" b="1" i="0">
                 <a:solidFill>
                   <a:srgbClr val="5A9E50"/>
                 </a:solidFill>
@@ -10279,39 +10147,148 @@
       </p:sp>
       <p:sp>
         <p:nvSpPr>
+          <p:cNvPr id="28" name="TextBox 27"/>
+          <p:cNvSpPr txBox="1"/>
+          <p:nvPr/>
+        </p:nvSpPr>
+        <p:spPr>
+          <a:xfrm>
+            <a:off x="731520" y="6080760"/>
+            <a:ext cx="6080760" cy="548640"/>
+          </a:xfrm>
+          <a:prstGeom prst="rect">
+            <a:avLst/>
+          </a:prstGeom>
+          <a:noFill/>
+        </p:spPr>
+        <p:txBody>
+          <a:bodyPr wrap="square" anchor="t" lIns="0" rIns="0" tIns="0" bIns="0">
+            <a:spAutoFit/>
+          </a:bodyPr>
+          <a:lstStyle/>
+          <a:p>
+            <a:pPr algn="l">
+              <a:lnSpc>
+                <a:spcPct val="105000"/>
+              </a:lnSpc>
+            </a:pPr>
+            <a:r>
+              <a:rPr sz="1000" b="0" i="0">
+                <a:solidFill>
+                  <a:srgbClr val="B8D9B2"/>
+                </a:solidFill>
+                <a:latin typeface="Calibri"/>
+              </a:rPr>
+              <a:t>Redesim (Node.js/Puppeteer) para abertura de empresa, e Consulta e-CAC (Python/Playwright) para declaração de IR — ambos com confirmação humana antes de agir.</a:t>
+            </a:r>
+          </a:p>
+        </p:txBody>
+      </p:sp>
+      <p:sp>
+        <p:nvSpPr>
+          <p:cNvPr id="29" name="Rounded Rectangle 28"/>
+          <p:cNvSpPr/>
+          <p:nvPr/>
+        </p:nvSpPr>
+        <p:spPr>
+          <a:xfrm>
+            <a:off x="7306056" y="1819656"/>
+            <a:ext cx="4407408" cy="3815926"/>
+          </a:xfrm>
+          <a:prstGeom prst="roundRect">
+            <a:avLst>
+              <a:gd name="adj" fmla="val 2000"/>
+            </a:avLst>
+          </a:prstGeom>
+          <a:solidFill>
+            <a:srgbClr val="FFFFFF"/>
+          </a:solidFill>
+          <a:ln>
+            <a:noFill/>
+          </a:ln>
+          <a:effectLst/>
+        </p:spPr>
+        <p:style>
+          <a:lnRef idx="1">
+            <a:schemeClr val="accent1"/>
+          </a:lnRef>
+          <a:fillRef idx="3">
+            <a:schemeClr val="accent1"/>
+          </a:fillRef>
+          <a:effectRef idx="2">
+            <a:schemeClr val="accent1"/>
+          </a:effectRef>
+          <a:fontRef idx="minor">
+            <a:schemeClr val="lt1"/>
+          </a:fontRef>
+        </p:style>
+        <p:txBody>
+          <a:bodyPr rtlCol="0" anchor="ctr"/>
+          <a:lstStyle/>
+          <a:p>
+            <a:pPr algn="ctr"/>
+          </a:p>
+        </p:txBody>
+      </p:sp>
+      <p:pic>
+        <p:nvPicPr>
+          <p:cNvPr id="30" name="Picture 29" descr="Aplicação.png"/>
+          <p:cNvPicPr>
+            <a:picLocks noChangeAspect="1"/>
+          </p:cNvPicPr>
+          <p:nvPr/>
+        </p:nvPicPr>
+        <p:blipFill>
+          <a:blip r:embed="rId2"/>
+          <a:stretch>
+            <a:fillRect/>
+          </a:stretch>
+        </p:blipFill>
+        <p:spPr>
+          <a:xfrm>
+            <a:off x="7360920" y="1874520"/>
+            <a:ext cx="4297680" cy="3706198"/>
+          </a:xfrm>
+          <a:prstGeom prst="rect">
+            <a:avLst/>
+          </a:prstGeom>
+        </p:spPr>
+      </p:pic>
+      <p:sp>
+        <p:nvSpPr>
           <p:cNvPr id="31" name="TextBox 30"/>
           <p:cNvSpPr txBox="1"/>
           <p:nvPr/>
         </p:nvSpPr>
         <p:spPr>
           <a:xfrm>
-            <a:off x="777240" y="4846320"/>
-            <a:ext cx="10607040" cy="411480"/>
-          </a:xfrm>
-          <a:prstGeom prst="rect">
-            <a:avLst/>
-          </a:prstGeom>
-          <a:noFill/>
-        </p:spPr>
-        <p:txBody>
-          <a:bodyPr wrap="square" anchor="t" lIns="0" rIns="0" tIns="0" bIns="0">
-            <a:spAutoFit/>
-          </a:bodyPr>
-          <a:lstStyle/>
-          <a:p>
-            <a:pPr algn="l">
-              <a:lnSpc>
-                <a:spcPct val="105000"/>
-              </a:lnSpc>
-            </a:pPr>
-            <a:r>
-              <a:rPr sz="1100" b="0" i="0">
+            <a:off x="7360920" y="5717878"/>
+            <a:ext cx="4297680" cy="320040"/>
+          </a:xfrm>
+          <a:prstGeom prst="rect">
+            <a:avLst/>
+          </a:prstGeom>
+          <a:noFill/>
+        </p:spPr>
+        <p:txBody>
+          <a:bodyPr wrap="square" anchor="t" lIns="0" rIns="0" tIns="0" bIns="0">
+            <a:spAutoFit/>
+          </a:bodyPr>
+          <a:lstStyle/>
+          <a:p>
+            <a:pPr algn="ctr">
+              <a:lnSpc>
+                <a:spcPct val="100000"/>
+              </a:lnSpc>
+            </a:pPr>
+            <a:r>
+              <a:rPr sz="1000" b="0" i="1">
                 <a:solidFill>
                   <a:srgbClr val="B8D9B2"/>
                 </a:solidFill>
                 <a:latin typeface="Calibri"/>
               </a:rPr>
-              <a:t>Redesim (Node.js/Puppeteer) para abertura de empresa, e Consulta e-CAC (Python/Playwright) para declaração de IR — ambos com confirmação humana antes de agir.</a:t>
+              <a:t>Dashboard real: extração por IA e RPA em ação</a:t>
             </a:r>
           </a:p>
         </p:txBody>

</xml_diff>